<commit_message>
Fix .gitignore to keep Doc PDFs tracked + update presentation (submission-ready)
</commit_message>
<xml_diff>
--- a/Doc/CoachAI_Presentation.pptx
+++ b/Doc/CoachAI_Presentation.pptx
@@ -5,18 +5,18 @@
     <p:sldMasterId id="2147483648" r:id="rId1"/>
   </p:sldMasterIdLst>
   <p:sldIdLst>
-    <p:sldId id="256" r:id="rId7"/>
-    <p:sldId id="257" r:id="rId8"/>
-    <p:sldId id="258" r:id="rId9"/>
-    <p:sldId id="259" r:id="rId10"/>
-    <p:sldId id="260" r:id="rId11"/>
-    <p:sldId id="261" r:id="rId12"/>
-    <p:sldId id="262" r:id="rId13"/>
-    <p:sldId id="263" r:id="rId14"/>
-    <p:sldId id="264" r:id="rId15"/>
-    <p:sldId id="265" r:id="rId16"/>
+    <p:sldId id="256" r:id="rId2"/>
+    <p:sldId id="257" r:id="rId3"/>
+    <p:sldId id="258" r:id="rId4"/>
+    <p:sldId id="259" r:id="rId5"/>
+    <p:sldId id="260" r:id="rId6"/>
+    <p:sldId id="261" r:id="rId7"/>
+    <p:sldId id="262" r:id="rId8"/>
+    <p:sldId id="263" r:id="rId9"/>
+    <p:sldId id="264" r:id="rId10"/>
+    <p:sldId id="265" r:id="rId11"/>
   </p:sldIdLst>
-  <p:sldSz cx="12191695" cy="6858000" type="screen4x3"/>
+  <p:sldSz cx="12192000" cy="6858000"/>
   <p:notesSz cx="6858000" cy="9144000"/>
   <p:defaultTextStyle>
     <a:defPPr>
@@ -113,6 +113,22 @@
       </a:defRPr>
     </a:lvl9pPr>
   </p:defaultTextStyle>
+  <p:extLst>
+    <p:ext uri="{EFAFB233-063F-42B5-8137-9DF3F51BA10A}">
+      <p15:sldGuideLst xmlns:p15="http://schemas.microsoft.com/office/powerpoint/2012/main">
+        <p15:guide id="1" orient="horz" pos="2160">
+          <p15:clr>
+            <a:srgbClr val="A4A3A4"/>
+          </p15:clr>
+        </p15:guide>
+        <p15:guide id="2" pos="2880">
+          <p15:clr>
+            <a:srgbClr val="A4A3A4"/>
+          </p15:clr>
+        </p15:guide>
+      </p15:sldGuideLst>
+    </p:ext>
+  </p:extLst>
 </p:presentation>
 </file>
 
@@ -154,10 +170,9 @@
           <a:lstStyle/>
           <a:p>
             <a:r>
-              <a:rPr lang="en-US" smtClean="0"/>
+              <a:rPr lang="en-US"/>
               <a:t>Click to edit Master title style</a:t>
             </a:r>
-            <a:endParaRPr lang="en-US"/>
           </a:p>
         </p:txBody>
       </p:sp>
@@ -273,10 +288,9 @@
           </a:lstStyle>
           <a:p>
             <a:r>
-              <a:rPr lang="en-US" smtClean="0"/>
+              <a:rPr lang="en-US"/>
               <a:t>Click to edit Master subtitle style</a:t>
             </a:r>
-            <a:endParaRPr lang="en-US"/>
           </a:p>
         </p:txBody>
       </p:sp>
@@ -297,7 +311,7 @@
           <a:p>
             <a:fld id="{5BCAD085-E8A6-8845-BD4E-CB4CCA059FC4}" type="datetimeFigureOut">
               <a:rPr lang="en-US" smtClean="0"/>
-              <a:t>1/27/13</a:t>
+              <a:t>8/19/2026</a:t>
             </a:fld>
             <a:endParaRPr lang="en-US"/>
           </a:p>
@@ -391,10 +405,9 @@
           <a:lstStyle/>
           <a:p>
             <a:r>
-              <a:rPr lang="en-US" smtClean="0"/>
+              <a:rPr lang="en-US"/>
               <a:t>Click to edit Master title style</a:t>
             </a:r>
-            <a:endParaRPr lang="en-US"/>
           </a:p>
         </p:txBody>
       </p:sp>
@@ -415,38 +428,37 @@
           <a:p>
             <a:pPr lvl="0"/>
             <a:r>
-              <a:rPr lang="en-US" smtClean="0"/>
+              <a:rPr lang="en-US"/>
               <a:t>Click to edit Master text styles</a:t>
             </a:r>
           </a:p>
           <a:p>
             <a:pPr lvl="1"/>
             <a:r>
-              <a:rPr lang="en-US" smtClean="0"/>
+              <a:rPr lang="en-US"/>
               <a:t>Second level</a:t>
             </a:r>
           </a:p>
           <a:p>
             <a:pPr lvl="2"/>
             <a:r>
-              <a:rPr lang="en-US" smtClean="0"/>
+              <a:rPr lang="en-US"/>
               <a:t>Third level</a:t>
             </a:r>
           </a:p>
           <a:p>
             <a:pPr lvl="3"/>
             <a:r>
-              <a:rPr lang="en-US" smtClean="0"/>
+              <a:rPr lang="en-US"/>
               <a:t>Fourth level</a:t>
             </a:r>
           </a:p>
           <a:p>
             <a:pPr lvl="4"/>
             <a:r>
-              <a:rPr lang="en-US" smtClean="0"/>
+              <a:rPr lang="en-US"/>
               <a:t>Fifth level</a:t>
             </a:r>
-            <a:endParaRPr lang="en-US"/>
           </a:p>
         </p:txBody>
       </p:sp>
@@ -467,7 +479,7 @@
           <a:p>
             <a:fld id="{5BCAD085-E8A6-8845-BD4E-CB4CCA059FC4}" type="datetimeFigureOut">
               <a:rPr lang="en-US" smtClean="0"/>
-              <a:t>1/27/13</a:t>
+              <a:t>8/19/2026</a:t>
             </a:fld>
             <a:endParaRPr lang="en-US"/>
           </a:p>
@@ -566,10 +578,9 @@
           <a:lstStyle/>
           <a:p>
             <a:r>
-              <a:rPr lang="en-US" smtClean="0"/>
+              <a:rPr lang="en-US"/>
               <a:t>Click to edit Master title style</a:t>
             </a:r>
-            <a:endParaRPr lang="en-US"/>
           </a:p>
         </p:txBody>
       </p:sp>
@@ -595,38 +606,37 @@
           <a:p>
             <a:pPr lvl="0"/>
             <a:r>
-              <a:rPr lang="en-US" smtClean="0"/>
+              <a:rPr lang="en-US"/>
               <a:t>Click to edit Master text styles</a:t>
             </a:r>
           </a:p>
           <a:p>
             <a:pPr lvl="1"/>
             <a:r>
-              <a:rPr lang="en-US" smtClean="0"/>
+              <a:rPr lang="en-US"/>
               <a:t>Second level</a:t>
             </a:r>
           </a:p>
           <a:p>
             <a:pPr lvl="2"/>
             <a:r>
-              <a:rPr lang="en-US" smtClean="0"/>
+              <a:rPr lang="en-US"/>
               <a:t>Third level</a:t>
             </a:r>
           </a:p>
           <a:p>
             <a:pPr lvl="3"/>
             <a:r>
-              <a:rPr lang="en-US" smtClean="0"/>
+              <a:rPr lang="en-US"/>
               <a:t>Fourth level</a:t>
             </a:r>
           </a:p>
           <a:p>
             <a:pPr lvl="4"/>
             <a:r>
-              <a:rPr lang="en-US" smtClean="0"/>
+              <a:rPr lang="en-US"/>
               <a:t>Fifth level</a:t>
             </a:r>
-            <a:endParaRPr lang="en-US"/>
           </a:p>
         </p:txBody>
       </p:sp>
@@ -647,7 +657,7 @@
           <a:p>
             <a:fld id="{5BCAD085-E8A6-8845-BD4E-CB4CCA059FC4}" type="datetimeFigureOut">
               <a:rPr lang="en-US" smtClean="0"/>
-              <a:t>1/27/13</a:t>
+              <a:t>8/19/2026</a:t>
             </a:fld>
             <a:endParaRPr lang="en-US"/>
           </a:p>
@@ -741,10 +751,9 @@
           <a:lstStyle/>
           <a:p>
             <a:r>
-              <a:rPr lang="en-US" smtClean="0"/>
+              <a:rPr lang="en-US"/>
               <a:t>Click to edit Master title style</a:t>
             </a:r>
-            <a:endParaRPr lang="en-US"/>
           </a:p>
         </p:txBody>
       </p:sp>
@@ -765,38 +774,37 @@
           <a:p>
             <a:pPr lvl="0"/>
             <a:r>
-              <a:rPr lang="en-US" smtClean="0"/>
+              <a:rPr lang="en-US"/>
               <a:t>Click to edit Master text styles</a:t>
             </a:r>
           </a:p>
           <a:p>
             <a:pPr lvl="1"/>
             <a:r>
-              <a:rPr lang="en-US" smtClean="0"/>
+              <a:rPr lang="en-US"/>
               <a:t>Second level</a:t>
             </a:r>
           </a:p>
           <a:p>
             <a:pPr lvl="2"/>
             <a:r>
-              <a:rPr lang="en-US" smtClean="0"/>
+              <a:rPr lang="en-US"/>
               <a:t>Third level</a:t>
             </a:r>
           </a:p>
           <a:p>
             <a:pPr lvl="3"/>
             <a:r>
-              <a:rPr lang="en-US" smtClean="0"/>
+              <a:rPr lang="en-US"/>
               <a:t>Fourth level</a:t>
             </a:r>
           </a:p>
           <a:p>
             <a:pPr lvl="4"/>
             <a:r>
-              <a:rPr lang="en-US" smtClean="0"/>
+              <a:rPr lang="en-US"/>
               <a:t>Fifth level</a:t>
             </a:r>
-            <a:endParaRPr lang="en-US"/>
           </a:p>
         </p:txBody>
       </p:sp>
@@ -817,7 +825,7 @@
           <a:p>
             <a:fld id="{5BCAD085-E8A6-8845-BD4E-CB4CCA059FC4}" type="datetimeFigureOut">
               <a:rPr lang="en-US" smtClean="0"/>
-              <a:t>1/27/13</a:t>
+              <a:t>8/19/2026</a:t>
             </a:fld>
             <a:endParaRPr lang="en-US"/>
           </a:p>
@@ -920,10 +928,9 @@
           </a:lstStyle>
           <a:p>
             <a:r>
-              <a:rPr lang="en-US" smtClean="0"/>
+              <a:rPr lang="en-US"/>
               <a:t>Click to edit Master title style</a:t>
             </a:r>
-            <a:endParaRPr lang="en-US"/>
           </a:p>
         </p:txBody>
       </p:sp>
@@ -1040,7 +1047,7 @@
           <a:p>
             <a:pPr lvl="0"/>
             <a:r>
-              <a:rPr lang="en-US" smtClean="0"/>
+              <a:rPr lang="en-US"/>
               <a:t>Click to edit Master text styles</a:t>
             </a:r>
           </a:p>
@@ -1063,7 +1070,7 @@
           <a:p>
             <a:fld id="{5BCAD085-E8A6-8845-BD4E-CB4CCA059FC4}" type="datetimeFigureOut">
               <a:rPr lang="en-US" smtClean="0"/>
-              <a:t>1/27/13</a:t>
+              <a:t>8/19/2026</a:t>
             </a:fld>
             <a:endParaRPr lang="en-US"/>
           </a:p>
@@ -1157,10 +1164,9 @@
           <a:lstStyle/>
           <a:p>
             <a:r>
-              <a:rPr lang="en-US" smtClean="0"/>
+              <a:rPr lang="en-US"/>
               <a:t>Click to edit Master title style</a:t>
             </a:r>
-            <a:endParaRPr lang="en-US"/>
           </a:p>
         </p:txBody>
       </p:sp>
@@ -1214,38 +1220,37 @@
           <a:p>
             <a:pPr lvl="0"/>
             <a:r>
-              <a:rPr lang="en-US" smtClean="0"/>
+              <a:rPr lang="en-US"/>
               <a:t>Click to edit Master text styles</a:t>
             </a:r>
           </a:p>
           <a:p>
             <a:pPr lvl="1"/>
             <a:r>
-              <a:rPr lang="en-US" smtClean="0"/>
+              <a:rPr lang="en-US"/>
               <a:t>Second level</a:t>
             </a:r>
           </a:p>
           <a:p>
             <a:pPr lvl="2"/>
             <a:r>
-              <a:rPr lang="en-US" smtClean="0"/>
+              <a:rPr lang="en-US"/>
               <a:t>Third level</a:t>
             </a:r>
           </a:p>
           <a:p>
             <a:pPr lvl="3"/>
             <a:r>
-              <a:rPr lang="en-US" smtClean="0"/>
+              <a:rPr lang="en-US"/>
               <a:t>Fourth level</a:t>
             </a:r>
           </a:p>
           <a:p>
             <a:pPr lvl="4"/>
             <a:r>
-              <a:rPr lang="en-US" smtClean="0"/>
+              <a:rPr lang="en-US"/>
               <a:t>Fifth level</a:t>
             </a:r>
-            <a:endParaRPr lang="en-US"/>
           </a:p>
         </p:txBody>
       </p:sp>
@@ -1299,38 +1304,37 @@
           <a:p>
             <a:pPr lvl="0"/>
             <a:r>
-              <a:rPr lang="en-US" smtClean="0"/>
+              <a:rPr lang="en-US"/>
               <a:t>Click to edit Master text styles</a:t>
             </a:r>
           </a:p>
           <a:p>
             <a:pPr lvl="1"/>
             <a:r>
-              <a:rPr lang="en-US" smtClean="0"/>
+              <a:rPr lang="en-US"/>
               <a:t>Second level</a:t>
             </a:r>
           </a:p>
           <a:p>
             <a:pPr lvl="2"/>
             <a:r>
-              <a:rPr lang="en-US" smtClean="0"/>
+              <a:rPr lang="en-US"/>
               <a:t>Third level</a:t>
             </a:r>
           </a:p>
           <a:p>
             <a:pPr lvl="3"/>
             <a:r>
-              <a:rPr lang="en-US" smtClean="0"/>
+              <a:rPr lang="en-US"/>
               <a:t>Fourth level</a:t>
             </a:r>
           </a:p>
           <a:p>
             <a:pPr lvl="4"/>
             <a:r>
-              <a:rPr lang="en-US" smtClean="0"/>
+              <a:rPr lang="en-US"/>
               <a:t>Fifth level</a:t>
             </a:r>
-            <a:endParaRPr lang="en-US"/>
           </a:p>
         </p:txBody>
       </p:sp>
@@ -1351,7 +1355,7 @@
           <a:p>
             <a:fld id="{5BCAD085-E8A6-8845-BD4E-CB4CCA059FC4}" type="datetimeFigureOut">
               <a:rPr lang="en-US" smtClean="0"/>
-              <a:t>1/27/13</a:t>
+              <a:t>8/19/2026</a:t>
             </a:fld>
             <a:endParaRPr lang="en-US"/>
           </a:p>
@@ -1449,10 +1453,9 @@
           </a:lstStyle>
           <a:p>
             <a:r>
-              <a:rPr lang="en-US" smtClean="0"/>
+              <a:rPr lang="en-US"/>
               <a:t>Click to edit Master title style</a:t>
             </a:r>
-            <a:endParaRPr lang="en-US"/>
           </a:p>
         </p:txBody>
       </p:sp>
@@ -1515,7 +1518,7 @@
           <a:p>
             <a:pPr lvl="0"/>
             <a:r>
-              <a:rPr lang="en-US" smtClean="0"/>
+              <a:rPr lang="en-US"/>
               <a:t>Click to edit Master text styles</a:t>
             </a:r>
           </a:p>
@@ -1571,38 +1574,37 @@
           <a:p>
             <a:pPr lvl="0"/>
             <a:r>
-              <a:rPr lang="en-US" smtClean="0"/>
+              <a:rPr lang="en-US"/>
               <a:t>Click to edit Master text styles</a:t>
             </a:r>
           </a:p>
           <a:p>
             <a:pPr lvl="1"/>
             <a:r>
-              <a:rPr lang="en-US" smtClean="0"/>
+              <a:rPr lang="en-US"/>
               <a:t>Second level</a:t>
             </a:r>
           </a:p>
           <a:p>
             <a:pPr lvl="2"/>
             <a:r>
-              <a:rPr lang="en-US" smtClean="0"/>
+              <a:rPr lang="en-US"/>
               <a:t>Third level</a:t>
             </a:r>
           </a:p>
           <a:p>
             <a:pPr lvl="3"/>
             <a:r>
-              <a:rPr lang="en-US" smtClean="0"/>
+              <a:rPr lang="en-US"/>
               <a:t>Fourth level</a:t>
             </a:r>
           </a:p>
           <a:p>
             <a:pPr lvl="4"/>
             <a:r>
-              <a:rPr lang="en-US" smtClean="0"/>
+              <a:rPr lang="en-US"/>
               <a:t>Fifth level</a:t>
             </a:r>
-            <a:endParaRPr lang="en-US"/>
           </a:p>
         </p:txBody>
       </p:sp>
@@ -1665,7 +1667,7 @@
           <a:p>
             <a:pPr lvl="0"/>
             <a:r>
-              <a:rPr lang="en-US" smtClean="0"/>
+              <a:rPr lang="en-US"/>
               <a:t>Click to edit Master text styles</a:t>
             </a:r>
           </a:p>
@@ -1721,38 +1723,37 @@
           <a:p>
             <a:pPr lvl="0"/>
             <a:r>
-              <a:rPr lang="en-US" smtClean="0"/>
+              <a:rPr lang="en-US"/>
               <a:t>Click to edit Master text styles</a:t>
             </a:r>
           </a:p>
           <a:p>
             <a:pPr lvl="1"/>
             <a:r>
-              <a:rPr lang="en-US" smtClean="0"/>
+              <a:rPr lang="en-US"/>
               <a:t>Second level</a:t>
             </a:r>
           </a:p>
           <a:p>
             <a:pPr lvl="2"/>
             <a:r>
-              <a:rPr lang="en-US" smtClean="0"/>
+              <a:rPr lang="en-US"/>
               <a:t>Third level</a:t>
             </a:r>
           </a:p>
           <a:p>
             <a:pPr lvl="3"/>
             <a:r>
-              <a:rPr lang="en-US" smtClean="0"/>
+              <a:rPr lang="en-US"/>
               <a:t>Fourth level</a:t>
             </a:r>
           </a:p>
           <a:p>
             <a:pPr lvl="4"/>
             <a:r>
-              <a:rPr lang="en-US" smtClean="0"/>
+              <a:rPr lang="en-US"/>
               <a:t>Fifth level</a:t>
             </a:r>
-            <a:endParaRPr lang="en-US"/>
           </a:p>
         </p:txBody>
       </p:sp>
@@ -1773,7 +1774,7 @@
           <a:p>
             <a:fld id="{5BCAD085-E8A6-8845-BD4E-CB4CCA059FC4}" type="datetimeFigureOut">
               <a:rPr lang="en-US" smtClean="0"/>
-              <a:t>1/27/13</a:t>
+              <a:t>8/19/2026</a:t>
             </a:fld>
             <a:endParaRPr lang="en-US"/>
           </a:p>
@@ -1867,10 +1868,9 @@
           <a:lstStyle/>
           <a:p>
             <a:r>
-              <a:rPr lang="en-US" smtClean="0"/>
+              <a:rPr lang="en-US"/>
               <a:t>Click to edit Master title style</a:t>
             </a:r>
-            <a:endParaRPr lang="en-US"/>
           </a:p>
         </p:txBody>
       </p:sp>
@@ -1891,7 +1891,7 @@
           <a:p>
             <a:fld id="{5BCAD085-E8A6-8845-BD4E-CB4CCA059FC4}" type="datetimeFigureOut">
               <a:rPr lang="en-US" smtClean="0"/>
-              <a:t>1/27/13</a:t>
+              <a:t>8/19/2026</a:t>
             </a:fld>
             <a:endParaRPr lang="en-US"/>
           </a:p>
@@ -1986,7 +1986,7 @@
           <a:p>
             <a:fld id="{5BCAD085-E8A6-8845-BD4E-CB4CCA059FC4}" type="datetimeFigureOut">
               <a:rPr lang="en-US" smtClean="0"/>
-              <a:t>1/27/13</a:t>
+              <a:t>8/19/2026</a:t>
             </a:fld>
             <a:endParaRPr lang="en-US"/>
           </a:p>
@@ -2089,10 +2089,9 @@
           </a:lstStyle>
           <a:p>
             <a:r>
-              <a:rPr lang="en-US" smtClean="0"/>
+              <a:rPr lang="en-US"/>
               <a:t>Click to edit Master title style</a:t>
             </a:r>
-            <a:endParaRPr lang="en-US"/>
           </a:p>
         </p:txBody>
       </p:sp>
@@ -2146,38 +2145,37 @@
           <a:p>
             <a:pPr lvl="0"/>
             <a:r>
-              <a:rPr lang="en-US" smtClean="0"/>
+              <a:rPr lang="en-US"/>
               <a:t>Click to edit Master text styles</a:t>
             </a:r>
           </a:p>
           <a:p>
             <a:pPr lvl="1"/>
             <a:r>
-              <a:rPr lang="en-US" smtClean="0"/>
+              <a:rPr lang="en-US"/>
               <a:t>Second level</a:t>
             </a:r>
           </a:p>
           <a:p>
             <a:pPr lvl="2"/>
             <a:r>
-              <a:rPr lang="en-US" smtClean="0"/>
+              <a:rPr lang="en-US"/>
               <a:t>Third level</a:t>
             </a:r>
           </a:p>
           <a:p>
             <a:pPr lvl="3"/>
             <a:r>
-              <a:rPr lang="en-US" smtClean="0"/>
+              <a:rPr lang="en-US"/>
               <a:t>Fourth level</a:t>
             </a:r>
           </a:p>
           <a:p>
             <a:pPr lvl="4"/>
             <a:r>
-              <a:rPr lang="en-US" smtClean="0"/>
+              <a:rPr lang="en-US"/>
               <a:t>Fifth level</a:t>
             </a:r>
-            <a:endParaRPr lang="en-US"/>
           </a:p>
         </p:txBody>
       </p:sp>
@@ -2240,7 +2238,7 @@
           <a:p>
             <a:pPr lvl="0"/>
             <a:r>
-              <a:rPr lang="en-US" smtClean="0"/>
+              <a:rPr lang="en-US"/>
               <a:t>Click to edit Master text styles</a:t>
             </a:r>
           </a:p>
@@ -2263,7 +2261,7 @@
           <a:p>
             <a:fld id="{5BCAD085-E8A6-8845-BD4E-CB4CCA059FC4}" type="datetimeFigureOut">
               <a:rPr lang="en-US" smtClean="0"/>
-              <a:t>1/27/13</a:t>
+              <a:t>8/19/2026</a:t>
             </a:fld>
             <a:endParaRPr lang="en-US"/>
           </a:p>
@@ -2366,10 +2364,9 @@
           </a:lstStyle>
           <a:p>
             <a:r>
-              <a:rPr lang="en-US" smtClean="0"/>
+              <a:rPr lang="en-US"/>
               <a:t>Click to edit Master title style</a:t>
             </a:r>
-            <a:endParaRPr lang="en-US"/>
           </a:p>
         </p:txBody>
       </p:sp>
@@ -2493,7 +2490,7 @@
           <a:p>
             <a:pPr lvl="0"/>
             <a:r>
-              <a:rPr lang="en-US" smtClean="0"/>
+              <a:rPr lang="en-US"/>
               <a:t>Click to edit Master text styles</a:t>
             </a:r>
           </a:p>
@@ -2516,7 +2513,7 @@
           <a:p>
             <a:fld id="{5BCAD085-E8A6-8845-BD4E-CB4CCA059FC4}" type="datetimeFigureOut">
               <a:rPr lang="en-US" smtClean="0"/>
-              <a:t>1/27/13</a:t>
+              <a:t>8/19/2026</a:t>
             </a:fld>
             <a:endParaRPr lang="en-US"/>
           </a:p>
@@ -2625,10 +2622,9 @@
           <a:lstStyle/>
           <a:p>
             <a:r>
-              <a:rPr lang="en-US" smtClean="0"/>
+              <a:rPr lang="en-US"/>
               <a:t>Click to edit Master title style</a:t>
             </a:r>
-            <a:endParaRPr lang="en-US"/>
           </a:p>
         </p:txBody>
       </p:sp>
@@ -2659,38 +2655,37 @@
           <a:p>
             <a:pPr lvl="0"/>
             <a:r>
-              <a:rPr lang="en-US" smtClean="0"/>
+              <a:rPr lang="en-US"/>
               <a:t>Click to edit Master text styles</a:t>
             </a:r>
           </a:p>
           <a:p>
             <a:pPr lvl="1"/>
             <a:r>
-              <a:rPr lang="en-US" smtClean="0"/>
+              <a:rPr lang="en-US"/>
               <a:t>Second level</a:t>
             </a:r>
           </a:p>
           <a:p>
             <a:pPr lvl="2"/>
             <a:r>
-              <a:rPr lang="en-US" smtClean="0"/>
+              <a:rPr lang="en-US"/>
               <a:t>Third level</a:t>
             </a:r>
           </a:p>
           <a:p>
             <a:pPr lvl="3"/>
             <a:r>
-              <a:rPr lang="en-US" smtClean="0"/>
+              <a:rPr lang="en-US"/>
               <a:t>Fourth level</a:t>
             </a:r>
           </a:p>
           <a:p>
             <a:pPr lvl="4"/>
             <a:r>
-              <a:rPr lang="en-US" smtClean="0"/>
+              <a:rPr lang="en-US"/>
               <a:t>Fifth level</a:t>
             </a:r>
-            <a:endParaRPr lang="en-US"/>
           </a:p>
         </p:txBody>
       </p:sp>
@@ -2729,7 +2724,7 @@
           <a:p>
             <a:fld id="{5BCAD085-E8A6-8845-BD4E-CB4CCA059FC4}" type="datetimeFigureOut">
               <a:rPr lang="en-US" smtClean="0"/>
-              <a:t>1/27/13</a:t>
+              <a:t>8/19/2026</a:t>
             </a:fld>
             <a:endParaRPr lang="en-US"/>
           </a:p>
@@ -3088,7 +3083,7 @@
 </file>
 
 <file path=ppt/slides/slide1.xml><?xml version="1.0" encoding="utf-8"?>
-<p:sld xmlns:a="http://schemas.openxmlformats.org/drawingml/2006/main" xmlns:p="http://schemas.openxmlformats.org/presentationml/2006/main" xmlns:r="http://schemas.openxmlformats.org/officeDocument/2006/relationships">
+<p:sld xmlns:a="http://schemas.openxmlformats.org/drawingml/2006/main" xmlns:r="http://schemas.openxmlformats.org/officeDocument/2006/relationships" xmlns:p="http://schemas.openxmlformats.org/presentationml/2006/main">
   <p:cSld>
     <p:spTree>
       <p:nvGrpSpPr>
@@ -3096,7 +3091,14 @@
         <p:cNvGrpSpPr/>
         <p:nvPr/>
       </p:nvGrpSpPr>
-      <p:grpSpPr/>
+      <p:grpSpPr>
+        <a:xfrm>
+          <a:off x="0" y="0"/>
+          <a:ext cx="0" cy="0"/>
+          <a:chOff x="0" y="0"/>
+          <a:chExt cx="0" cy="0"/>
+        </a:xfrm>
+      </p:grpSpPr>
       <p:sp>
         <p:nvSpPr>
           <p:cNvPr id="2" name="Rectangle 1"/>
@@ -3138,6 +3140,7 @@
           <a:lstStyle/>
           <a:p>
             <a:pPr algn="ctr"/>
+            <a:endParaRPr/>
           </a:p>
         </p:txBody>
       </p:sp>
@@ -3182,6 +3185,7 @@
           <a:lstStyle/>
           <a:p>
             <a:pPr algn="ctr"/>
+            <a:endParaRPr/>
           </a:p>
         </p:txBody>
       </p:sp>
@@ -3226,6 +3230,7 @@
           <a:lstStyle/>
           <a:p>
             <a:pPr algn="ctr"/>
+            <a:endParaRPr/>
           </a:p>
         </p:txBody>
       </p:sp>
@@ -3415,6 +3420,7 @@
           <a:lstStyle/>
           <a:p>
             <a:pPr algn="ctr"/>
+            <a:endParaRPr/>
           </a:p>
         </p:txBody>
       </p:sp>
@@ -3456,48 +3462,6 @@
                 <a:latin typeface="Calibri"/>
               </a:rPr>
               <a:t>A multi-agent AI coaching cockpit that analyzes every customer message in real time — sentiment, intent, knowledge-base article, best reply, and escalation risk.</a:t>
-            </a:r>
-          </a:p>
-        </p:txBody>
-      </p:sp>
-      <p:sp>
-        <p:nvSpPr>
-          <p:cNvPr id="10" name="TextBox 9"/>
-          <p:cNvSpPr txBox="1"/>
-          <p:nvPr/>
-        </p:nvSpPr>
-        <p:spPr>
-          <a:xfrm>
-            <a:off x="1005840" y="5349240"/>
-            <a:ext cx="10149840" cy="731520"/>
-          </a:xfrm>
-          <a:prstGeom prst="rect">
-            <a:avLst/>
-          </a:prstGeom>
-          <a:noFill/>
-        </p:spPr>
-        <p:txBody>
-          <a:bodyPr wrap="square" anchor="t">
-            <a:spAutoFit/>
-          </a:bodyPr>
-          <a:lstStyle/>
-          <a:p>
-            <a:pPr algn="l">
-              <a:lnSpc>
-                <a:spcPct val="100000"/>
-              </a:lnSpc>
-              <a:spcAft>
-                <a:spcPts val="600"/>
-              </a:spcAft>
-            </a:pPr>
-            <a:r>
-              <a:rPr sz="1300" b="0">
-                <a:solidFill>
-                  <a:srgbClr val="9CADC8"/>
-                </a:solidFill>
-                <a:latin typeface="Calibri"/>
-              </a:rPr>
-              <a:t>Presented by:  [Team Member Names]         Mentor:  [Mentor Name]         Date:  August 2026</a:t>
             </a:r>
           </a:p>
         </p:txBody>
@@ -3595,7 +3559,7 @@
 </file>
 
 <file path=ppt/slides/slide10.xml><?xml version="1.0" encoding="utf-8"?>
-<p:sld xmlns:a="http://schemas.openxmlformats.org/drawingml/2006/main" xmlns:p="http://schemas.openxmlformats.org/presentationml/2006/main" xmlns:r="http://schemas.openxmlformats.org/officeDocument/2006/relationships">
+<p:sld xmlns:a="http://schemas.openxmlformats.org/drawingml/2006/main" xmlns:r="http://schemas.openxmlformats.org/officeDocument/2006/relationships" xmlns:p="http://schemas.openxmlformats.org/presentationml/2006/main">
   <p:cSld>
     <p:spTree>
       <p:nvGrpSpPr>
@@ -3603,7 +3567,14 @@
         <p:cNvGrpSpPr/>
         <p:nvPr/>
       </p:nvGrpSpPr>
-      <p:grpSpPr/>
+      <p:grpSpPr>
+        <a:xfrm>
+          <a:off x="0" y="0"/>
+          <a:ext cx="0" cy="0"/>
+          <a:chOff x="0" y="0"/>
+          <a:chExt cx="0" cy="0"/>
+        </a:xfrm>
+      </p:grpSpPr>
       <p:sp>
         <p:nvSpPr>
           <p:cNvPr id="2" name="Rectangle 1"/>
@@ -3645,6 +3616,7 @@
           <a:lstStyle/>
           <a:p>
             <a:pPr algn="ctr"/>
+            <a:endParaRPr/>
           </a:p>
         </p:txBody>
       </p:sp>
@@ -3689,6 +3661,7 @@
           <a:lstStyle/>
           <a:p>
             <a:pPr algn="ctr"/>
+            <a:endParaRPr/>
           </a:p>
         </p:txBody>
       </p:sp>
@@ -3733,6 +3706,7 @@
           <a:lstStyle/>
           <a:p>
             <a:pPr algn="ctr"/>
+            <a:endParaRPr/>
           </a:p>
         </p:txBody>
       </p:sp>
@@ -3819,6 +3793,7 @@
           <a:lstStyle/>
           <a:p>
             <a:pPr algn="ctr"/>
+            <a:endParaRPr/>
           </a:p>
         </p:txBody>
       </p:sp>
@@ -4041,7 +4016,7 @@
 </file>
 
 <file path=ppt/slides/slide2.xml><?xml version="1.0" encoding="utf-8"?>
-<p:sld xmlns:a="http://schemas.openxmlformats.org/drawingml/2006/main" xmlns:p="http://schemas.openxmlformats.org/presentationml/2006/main" xmlns:r="http://schemas.openxmlformats.org/officeDocument/2006/relationships">
+<p:sld xmlns:a="http://schemas.openxmlformats.org/drawingml/2006/main" xmlns:r="http://schemas.openxmlformats.org/officeDocument/2006/relationships" xmlns:p="http://schemas.openxmlformats.org/presentationml/2006/main">
   <p:cSld>
     <p:spTree>
       <p:nvGrpSpPr>
@@ -4049,7 +4024,14 @@
         <p:cNvGrpSpPr/>
         <p:nvPr/>
       </p:nvGrpSpPr>
-      <p:grpSpPr/>
+      <p:grpSpPr>
+        <a:xfrm>
+          <a:off x="0" y="0"/>
+          <a:ext cx="0" cy="0"/>
+          <a:chOff x="0" y="0"/>
+          <a:chExt cx="0" cy="0"/>
+        </a:xfrm>
+      </p:grpSpPr>
       <p:sp>
         <p:nvSpPr>
           <p:cNvPr id="2" name="Rectangle 1"/>
@@ -4091,6 +4073,7 @@
           <a:lstStyle/>
           <a:p>
             <a:pPr algn="ctr"/>
+            <a:endParaRPr/>
           </a:p>
         </p:txBody>
       </p:sp>
@@ -4135,6 +4118,7 @@
           <a:lstStyle/>
           <a:p>
             <a:pPr algn="ctr"/>
+            <a:endParaRPr/>
           </a:p>
         </p:txBody>
       </p:sp>
@@ -4221,6 +4205,7 @@
           <a:lstStyle/>
           <a:p>
             <a:pPr algn="ctr"/>
+            <a:endParaRPr/>
           </a:p>
         </p:txBody>
       </p:sp>
@@ -4520,6 +4505,7 @@
           <a:lstStyle/>
           <a:p>
             <a:pPr algn="ctr"/>
+            <a:endParaRPr/>
           </a:p>
         </p:txBody>
       </p:sp>
@@ -5005,7 +4991,7 @@
 </file>
 
 <file path=ppt/slides/slide3.xml><?xml version="1.0" encoding="utf-8"?>
-<p:sld xmlns:a="http://schemas.openxmlformats.org/drawingml/2006/main" xmlns:p="http://schemas.openxmlformats.org/presentationml/2006/main" xmlns:r="http://schemas.openxmlformats.org/officeDocument/2006/relationships">
+<p:sld xmlns:a="http://schemas.openxmlformats.org/drawingml/2006/main" xmlns:r="http://schemas.openxmlformats.org/officeDocument/2006/relationships" xmlns:p="http://schemas.openxmlformats.org/presentationml/2006/main">
   <p:cSld>
     <p:spTree>
       <p:nvGrpSpPr>
@@ -5013,7 +4999,14 @@
         <p:cNvGrpSpPr/>
         <p:nvPr/>
       </p:nvGrpSpPr>
-      <p:grpSpPr/>
+      <p:grpSpPr>
+        <a:xfrm>
+          <a:off x="0" y="0"/>
+          <a:ext cx="0" cy="0"/>
+          <a:chOff x="0" y="0"/>
+          <a:chExt cx="0" cy="0"/>
+        </a:xfrm>
+      </p:grpSpPr>
       <p:sp>
         <p:nvSpPr>
           <p:cNvPr id="2" name="Rectangle 1"/>
@@ -5055,6 +5048,7 @@
           <a:lstStyle/>
           <a:p>
             <a:pPr algn="ctr"/>
+            <a:endParaRPr/>
           </a:p>
         </p:txBody>
       </p:sp>
@@ -5099,6 +5093,7 @@
           <a:lstStyle/>
           <a:p>
             <a:pPr algn="ctr"/>
+            <a:endParaRPr/>
           </a:p>
         </p:txBody>
       </p:sp>
@@ -5185,6 +5180,7 @@
           <a:lstStyle/>
           <a:p>
             <a:pPr algn="ctr"/>
+            <a:endParaRPr/>
           </a:p>
         </p:txBody>
       </p:sp>
@@ -5697,6 +5693,7 @@
           <a:lstStyle/>
           <a:p>
             <a:pPr algn="ctr"/>
+            <a:endParaRPr/>
           </a:p>
         </p:txBody>
       </p:sp>
@@ -5835,7 +5832,7 @@
 </file>
 
 <file path=ppt/slides/slide4.xml><?xml version="1.0" encoding="utf-8"?>
-<p:sld xmlns:a="http://schemas.openxmlformats.org/drawingml/2006/main" xmlns:p="http://schemas.openxmlformats.org/presentationml/2006/main" xmlns:r="http://schemas.openxmlformats.org/officeDocument/2006/relationships">
+<p:sld xmlns:a="http://schemas.openxmlformats.org/drawingml/2006/main" xmlns:r="http://schemas.openxmlformats.org/officeDocument/2006/relationships" xmlns:p="http://schemas.openxmlformats.org/presentationml/2006/main">
   <p:cSld>
     <p:spTree>
       <p:nvGrpSpPr>
@@ -5843,7 +5840,14 @@
         <p:cNvGrpSpPr/>
         <p:nvPr/>
       </p:nvGrpSpPr>
-      <p:grpSpPr/>
+      <p:grpSpPr>
+        <a:xfrm>
+          <a:off x="0" y="0"/>
+          <a:ext cx="0" cy="0"/>
+          <a:chOff x="0" y="0"/>
+          <a:chExt cx="0" cy="0"/>
+        </a:xfrm>
+      </p:grpSpPr>
       <p:sp>
         <p:nvSpPr>
           <p:cNvPr id="2" name="Rectangle 1"/>
@@ -5885,6 +5889,7 @@
           <a:lstStyle/>
           <a:p>
             <a:pPr algn="ctr"/>
+            <a:endParaRPr/>
           </a:p>
         </p:txBody>
       </p:sp>
@@ -5929,6 +5934,7 @@
           <a:lstStyle/>
           <a:p>
             <a:pPr algn="ctr"/>
+            <a:endParaRPr/>
           </a:p>
         </p:txBody>
       </p:sp>
@@ -6015,6 +6021,7 @@
           <a:lstStyle/>
           <a:p>
             <a:pPr algn="ctr"/>
+            <a:endParaRPr/>
           </a:p>
         </p:txBody>
       </p:sp>
@@ -6101,6 +6108,7 @@
           <a:lstStyle/>
           <a:p>
             <a:pPr algn="ctr"/>
+            <a:endParaRPr/>
           </a:p>
         </p:txBody>
       </p:sp>
@@ -6229,6 +6237,7 @@
           <a:lstStyle/>
           <a:p>
             <a:pPr algn="ctr"/>
+            <a:endParaRPr/>
           </a:p>
         </p:txBody>
       </p:sp>
@@ -6357,6 +6366,7 @@
           <a:lstStyle/>
           <a:p>
             <a:pPr algn="ctr"/>
+            <a:endParaRPr/>
           </a:p>
         </p:txBody>
       </p:sp>
@@ -6485,6 +6495,7 @@
           <a:lstStyle/>
           <a:p>
             <a:pPr algn="ctr"/>
+            <a:endParaRPr/>
           </a:p>
         </p:txBody>
       </p:sp>
@@ -6613,6 +6624,7 @@
           <a:lstStyle/>
           <a:p>
             <a:pPr algn="ctr"/>
+            <a:endParaRPr/>
           </a:p>
         </p:txBody>
       </p:sp>
@@ -6741,6 +6753,7 @@
           <a:lstStyle/>
           <a:p>
             <a:pPr algn="ctr"/>
+            <a:endParaRPr/>
           </a:p>
         </p:txBody>
       </p:sp>
@@ -6869,6 +6882,7 @@
           <a:lstStyle/>
           <a:p>
             <a:pPr algn="ctr"/>
+            <a:endParaRPr/>
           </a:p>
         </p:txBody>
       </p:sp>
@@ -6997,6 +7011,7 @@
           <a:lstStyle/>
           <a:p>
             <a:pPr algn="ctr"/>
+            <a:endParaRPr/>
           </a:p>
         </p:txBody>
       </p:sp>
@@ -7177,7 +7192,7 @@
 </file>
 
 <file path=ppt/slides/slide5.xml><?xml version="1.0" encoding="utf-8"?>
-<p:sld xmlns:a="http://schemas.openxmlformats.org/drawingml/2006/main" xmlns:p="http://schemas.openxmlformats.org/presentationml/2006/main" xmlns:r="http://schemas.openxmlformats.org/officeDocument/2006/relationships">
+<p:sld xmlns:a="http://schemas.openxmlformats.org/drawingml/2006/main" xmlns:r="http://schemas.openxmlformats.org/officeDocument/2006/relationships" xmlns:p="http://schemas.openxmlformats.org/presentationml/2006/main">
   <p:cSld>
     <p:spTree>
       <p:nvGrpSpPr>
@@ -7185,7 +7200,14 @@
         <p:cNvGrpSpPr/>
         <p:nvPr/>
       </p:nvGrpSpPr>
-      <p:grpSpPr/>
+      <p:grpSpPr>
+        <a:xfrm>
+          <a:off x="0" y="0"/>
+          <a:ext cx="0" cy="0"/>
+          <a:chOff x="0" y="0"/>
+          <a:chExt cx="0" cy="0"/>
+        </a:xfrm>
+      </p:grpSpPr>
       <p:sp>
         <p:nvSpPr>
           <p:cNvPr id="2" name="Rectangle 1"/>
@@ -7227,6 +7249,7 @@
           <a:lstStyle/>
           <a:p>
             <a:pPr algn="ctr"/>
+            <a:endParaRPr/>
           </a:p>
         </p:txBody>
       </p:sp>
@@ -7271,6 +7294,7 @@
           <a:lstStyle/>
           <a:p>
             <a:pPr algn="ctr"/>
+            <a:endParaRPr/>
           </a:p>
         </p:txBody>
       </p:sp>
@@ -7399,6 +7423,7 @@
           <a:lstStyle/>
           <a:p>
             <a:pPr algn="ctr"/>
+            <a:endParaRPr/>
           </a:p>
         </p:txBody>
       </p:sp>
@@ -7651,6 +7676,7 @@
           <a:lstStyle/>
           <a:p>
             <a:pPr algn="ctr"/>
+            <a:endParaRPr/>
           </a:p>
         </p:txBody>
       </p:sp>
@@ -7960,7 +7986,7 @@
 </file>
 
 <file path=ppt/slides/slide6.xml><?xml version="1.0" encoding="utf-8"?>
-<p:sld xmlns:a="http://schemas.openxmlformats.org/drawingml/2006/main" xmlns:p="http://schemas.openxmlformats.org/presentationml/2006/main" xmlns:r="http://schemas.openxmlformats.org/officeDocument/2006/relationships">
+<p:sld xmlns:a="http://schemas.openxmlformats.org/drawingml/2006/main" xmlns:r="http://schemas.openxmlformats.org/officeDocument/2006/relationships" xmlns:p="http://schemas.openxmlformats.org/presentationml/2006/main">
   <p:cSld>
     <p:spTree>
       <p:nvGrpSpPr>
@@ -7968,7 +7994,14 @@
         <p:cNvGrpSpPr/>
         <p:nvPr/>
       </p:nvGrpSpPr>
-      <p:grpSpPr/>
+      <p:grpSpPr>
+        <a:xfrm>
+          <a:off x="0" y="0"/>
+          <a:ext cx="0" cy="0"/>
+          <a:chOff x="0" y="0"/>
+          <a:chExt cx="0" cy="0"/>
+        </a:xfrm>
+      </p:grpSpPr>
       <p:sp>
         <p:nvSpPr>
           <p:cNvPr id="2" name="Rectangle 1"/>
@@ -8010,6 +8043,7 @@
           <a:lstStyle/>
           <a:p>
             <a:pPr algn="ctr"/>
+            <a:endParaRPr/>
           </a:p>
         </p:txBody>
       </p:sp>
@@ -8054,6 +8088,7 @@
           <a:lstStyle/>
           <a:p>
             <a:pPr algn="ctr"/>
+            <a:endParaRPr/>
           </a:p>
         </p:txBody>
       </p:sp>
@@ -8182,6 +8217,7 @@
           <a:lstStyle/>
           <a:p>
             <a:pPr algn="ctr"/>
+            <a:endParaRPr/>
           </a:p>
         </p:txBody>
       </p:sp>
@@ -8434,6 +8470,7 @@
           <a:lstStyle/>
           <a:p>
             <a:pPr algn="ctr"/>
+            <a:endParaRPr/>
           </a:p>
         </p:txBody>
       </p:sp>
@@ -8743,7 +8780,7 @@
 </file>
 
 <file path=ppt/slides/slide7.xml><?xml version="1.0" encoding="utf-8"?>
-<p:sld xmlns:a="http://schemas.openxmlformats.org/drawingml/2006/main" xmlns:p="http://schemas.openxmlformats.org/presentationml/2006/main" xmlns:r="http://schemas.openxmlformats.org/officeDocument/2006/relationships">
+<p:sld xmlns:a="http://schemas.openxmlformats.org/drawingml/2006/main" xmlns:r="http://schemas.openxmlformats.org/officeDocument/2006/relationships" xmlns:p="http://schemas.openxmlformats.org/presentationml/2006/main">
   <p:cSld>
     <p:spTree>
       <p:nvGrpSpPr>
@@ -8751,7 +8788,14 @@
         <p:cNvGrpSpPr/>
         <p:nvPr/>
       </p:nvGrpSpPr>
-      <p:grpSpPr/>
+      <p:grpSpPr>
+        <a:xfrm>
+          <a:off x="0" y="0"/>
+          <a:ext cx="0" cy="0"/>
+          <a:chOff x="0" y="0"/>
+          <a:chExt cx="0" cy="0"/>
+        </a:xfrm>
+      </p:grpSpPr>
       <p:sp>
         <p:nvSpPr>
           <p:cNvPr id="2" name="Rectangle 1"/>
@@ -8793,6 +8837,7 @@
           <a:lstStyle/>
           <a:p>
             <a:pPr algn="ctr"/>
+            <a:endParaRPr/>
           </a:p>
         </p:txBody>
       </p:sp>
@@ -8837,6 +8882,7 @@
           <a:lstStyle/>
           <a:p>
             <a:pPr algn="ctr"/>
+            <a:endParaRPr/>
           </a:p>
         </p:txBody>
       </p:sp>
@@ -8965,6 +9011,7 @@
           <a:lstStyle/>
           <a:p>
             <a:pPr algn="ctr"/>
+            <a:endParaRPr/>
           </a:p>
         </p:txBody>
       </p:sp>
@@ -9217,6 +9264,7 @@
           <a:lstStyle/>
           <a:p>
             <a:pPr algn="ctr"/>
+            <a:endParaRPr/>
           </a:p>
         </p:txBody>
       </p:sp>
@@ -9526,7 +9574,7 @@
 </file>
 
 <file path=ppt/slides/slide8.xml><?xml version="1.0" encoding="utf-8"?>
-<p:sld xmlns:a="http://schemas.openxmlformats.org/drawingml/2006/main" xmlns:p="http://schemas.openxmlformats.org/presentationml/2006/main" xmlns:r="http://schemas.openxmlformats.org/officeDocument/2006/relationships">
+<p:sld xmlns:a="http://schemas.openxmlformats.org/drawingml/2006/main" xmlns:r="http://schemas.openxmlformats.org/officeDocument/2006/relationships" xmlns:p="http://schemas.openxmlformats.org/presentationml/2006/main">
   <p:cSld>
     <p:spTree>
       <p:nvGrpSpPr>
@@ -9534,7 +9582,14 @@
         <p:cNvGrpSpPr/>
         <p:nvPr/>
       </p:nvGrpSpPr>
-      <p:grpSpPr/>
+      <p:grpSpPr>
+        <a:xfrm>
+          <a:off x="0" y="0"/>
+          <a:ext cx="0" cy="0"/>
+          <a:chOff x="0" y="0"/>
+          <a:chExt cx="0" cy="0"/>
+        </a:xfrm>
+      </p:grpSpPr>
       <p:sp>
         <p:nvSpPr>
           <p:cNvPr id="2" name="Rectangle 1"/>
@@ -9576,6 +9631,7 @@
           <a:lstStyle/>
           <a:p>
             <a:pPr algn="ctr"/>
+            <a:endParaRPr/>
           </a:p>
         </p:txBody>
       </p:sp>
@@ -9620,6 +9676,7 @@
           <a:lstStyle/>
           <a:p>
             <a:pPr algn="ctr"/>
+            <a:endParaRPr/>
           </a:p>
         </p:txBody>
       </p:sp>
@@ -9706,6 +9763,7 @@
           <a:lstStyle/>
           <a:p>
             <a:pPr algn="ctr"/>
+            <a:endParaRPr/>
           </a:p>
         </p:txBody>
       </p:sp>
@@ -10228,7 +10286,7 @@
 </file>
 
 <file path=ppt/slides/slide9.xml><?xml version="1.0" encoding="utf-8"?>
-<p:sld xmlns:a="http://schemas.openxmlformats.org/drawingml/2006/main" xmlns:p="http://schemas.openxmlformats.org/presentationml/2006/main" xmlns:r="http://schemas.openxmlformats.org/officeDocument/2006/relationships">
+<p:sld xmlns:a="http://schemas.openxmlformats.org/drawingml/2006/main" xmlns:r="http://schemas.openxmlformats.org/officeDocument/2006/relationships" xmlns:p="http://schemas.openxmlformats.org/presentationml/2006/main">
   <p:cSld>
     <p:spTree>
       <p:nvGrpSpPr>
@@ -10236,7 +10294,14 @@
         <p:cNvGrpSpPr/>
         <p:nvPr/>
       </p:nvGrpSpPr>
-      <p:grpSpPr/>
+      <p:grpSpPr>
+        <a:xfrm>
+          <a:off x="0" y="0"/>
+          <a:ext cx="0" cy="0"/>
+          <a:chOff x="0" y="0"/>
+          <a:chExt cx="0" cy="0"/>
+        </a:xfrm>
+      </p:grpSpPr>
       <p:sp>
         <p:nvSpPr>
           <p:cNvPr id="2" name="Rectangle 1"/>
@@ -10278,6 +10343,7 @@
           <a:lstStyle/>
           <a:p>
             <a:pPr algn="ctr"/>
+            <a:endParaRPr/>
           </a:p>
         </p:txBody>
       </p:sp>
@@ -10322,6 +10388,7 @@
           <a:lstStyle/>
           <a:p>
             <a:pPr algn="ctr"/>
+            <a:endParaRPr/>
           </a:p>
         </p:txBody>
       </p:sp>
@@ -10408,6 +10475,7 @@
           <a:lstStyle/>
           <a:p>
             <a:pPr algn="ctr"/>
+            <a:endParaRPr/>
           </a:p>
         </p:txBody>
       </p:sp>

</xml_diff>